<commit_message>
vault: sync from ubuntu-4gb-hel1-1 @ 2026-05-06T08:28:57Z
</commit_message>
<xml_diff>
--- a/Fredis/Memory/drafts/active/product-shape/vtv-bartisevics-deck-2026-05-18.pptx
+++ b/Fredis/Memory/drafts/active/product-shape/vtv-bartisevics-deck-2026-05-18.pptx
@@ -7615,7 +7615,7 @@
                 </a:solidFill>
                 <a:latin typeface="Montserrat Ace"/>
               </a:rPr>
-              <a:t>05  ·  MECE</a:t>
+              <a:t>05  ·  DECISION</a:t>
             </a:r>
           </a:p>
         </p:txBody>
@@ -7654,7 +7654,7 @@
                 </a:solidFill>
                 <a:latin typeface="Homizio"/>
               </a:rPr>
-              <a:t>How to choose — mutually exclusive, collectively exhaustive</a:t>
+              <a:t>The four realistic paths — scored on what Council will ask</a:t>
             </a:r>
           </a:p>
         </p:txBody>
@@ -7705,13 +7705,52 @@
       </p:sp>
       <p:sp>
         <p:nvSpPr>
-          <p:cNvPr id="7" name="Rectangle 6"/>
+          <p:cNvPr id="7" name="TextBox 6"/>
+          <p:cNvSpPr txBox="1"/>
+          <p:nvPr/>
+        </p:nvSpPr>
+        <p:spPr>
+          <a:xfrm>
+            <a:off x="640080" y="1554480"/>
+            <a:ext cx="10972800" cy="320040"/>
+          </a:xfrm>
+          <a:prstGeom prst="rect">
+            <a:avLst/>
+          </a:prstGeom>
+          <a:noFill/>
+        </p:spPr>
+        <p:txBody>
+          <a:bodyPr wrap="square" lIns="0" rIns="0" tIns="0" bIns="0">
+            <a:spAutoFit/>
+          </a:bodyPr>
+          <a:lstStyle/>
+          <a:p>
+            <a:pPr algn="l">
+              <a:lnSpc>
+                <a:spcPct val="120000"/>
+              </a:lnSpc>
+            </a:pPr>
+            <a:r>
+              <a:rPr sz="1300" b="0">
+                <a:solidFill>
+                  <a:srgbClr val="5A5A5A"/>
+                </a:solidFill>
+                <a:latin typeface="Montserrat Ace"/>
+              </a:rPr>
+              <a:t>Every modernisation option, compared on four criteria.</a:t>
+            </a:r>
+          </a:p>
+        </p:txBody>
+      </p:sp>
+      <p:sp>
+        <p:nvSpPr>
+          <p:cNvPr id="8" name="Rectangle 7"/>
           <p:cNvSpPr/>
           <p:nvPr/>
         </p:nvSpPr>
         <p:spPr>
           <a:xfrm>
-            <a:off x="640080" y="1828800"/>
+            <a:off x="640080" y="1965960"/>
             <a:ext cx="10972800" cy="502920"/>
           </a:xfrm>
           <a:prstGeom prst="rect">
@@ -7749,13 +7788,13 @@
       </p:sp>
       <p:sp>
         <p:nvSpPr>
-          <p:cNvPr id="8" name="TextBox 7"/>
+          <p:cNvPr id="9" name="TextBox 8"/>
           <p:cNvSpPr txBox="1"/>
           <p:nvPr/>
         </p:nvSpPr>
         <p:spPr>
           <a:xfrm>
-            <a:off x="777240" y="1938528"/>
+            <a:off x="777240" y="2075688"/>
             <a:ext cx="2926080" cy="502920"/>
           </a:xfrm>
           <a:prstGeom prst="rect">
@@ -7788,13 +7827,13 @@
       </p:sp>
       <p:sp>
         <p:nvSpPr>
-          <p:cNvPr id="9" name="TextBox 8"/>
+          <p:cNvPr id="10" name="TextBox 9"/>
           <p:cNvSpPr txBox="1"/>
           <p:nvPr/>
         </p:nvSpPr>
         <p:spPr>
           <a:xfrm>
-            <a:off x="3886200" y="1938528"/>
+            <a:off x="3886200" y="2075688"/>
             <a:ext cx="1097279" cy="502920"/>
           </a:xfrm>
           <a:prstGeom prst="rect">
@@ -7827,13 +7866,13 @@
       </p:sp>
       <p:sp>
         <p:nvSpPr>
-          <p:cNvPr id="10" name="TextBox 9"/>
+          <p:cNvPr id="11" name="TextBox 10"/>
           <p:cNvSpPr txBox="1"/>
           <p:nvPr/>
         </p:nvSpPr>
         <p:spPr>
           <a:xfrm>
-            <a:off x="5166359" y="1938528"/>
+            <a:off x="5166359" y="2075688"/>
             <a:ext cx="1097279" cy="502920"/>
           </a:xfrm>
           <a:prstGeom prst="rect">
@@ -7866,13 +7905,13 @@
       </p:sp>
       <p:sp>
         <p:nvSpPr>
-          <p:cNvPr id="11" name="TextBox 10"/>
+          <p:cNvPr id="12" name="TextBox 11"/>
           <p:cNvSpPr txBox="1"/>
           <p:nvPr/>
         </p:nvSpPr>
         <p:spPr>
           <a:xfrm>
-            <a:off x="6446518" y="1938528"/>
+            <a:off x="6446518" y="2075688"/>
             <a:ext cx="1371600" cy="502920"/>
           </a:xfrm>
           <a:prstGeom prst="rect">
@@ -7905,13 +7944,13 @@
       </p:sp>
       <p:sp>
         <p:nvSpPr>
-          <p:cNvPr id="12" name="TextBox 11"/>
+          <p:cNvPr id="13" name="TextBox 12"/>
           <p:cNvSpPr txBox="1"/>
           <p:nvPr/>
         </p:nvSpPr>
         <p:spPr>
           <a:xfrm>
-            <a:off x="8000998" y="1938528"/>
+            <a:off x="8000998" y="2075688"/>
             <a:ext cx="1097279" cy="502920"/>
           </a:xfrm>
           <a:prstGeom prst="rect">
@@ -7944,13 +7983,13 @@
       </p:sp>
       <p:sp>
         <p:nvSpPr>
-          <p:cNvPr id="13" name="TextBox 12"/>
+          <p:cNvPr id="14" name="TextBox 13"/>
           <p:cNvSpPr txBox="1"/>
           <p:nvPr/>
         </p:nvSpPr>
         <p:spPr>
           <a:xfrm>
-            <a:off x="9281157" y="1938528"/>
+            <a:off x="9281157" y="2075688"/>
             <a:ext cx="2286000" cy="502920"/>
           </a:xfrm>
           <a:prstGeom prst="rect">
@@ -7983,13 +8022,13 @@
       </p:sp>
       <p:sp>
         <p:nvSpPr>
-          <p:cNvPr id="14" name="Rectangle 13"/>
+          <p:cNvPr id="15" name="Rectangle 14"/>
           <p:cNvSpPr/>
           <p:nvPr/>
         </p:nvSpPr>
         <p:spPr>
           <a:xfrm>
-            <a:off x="640080" y="2331720"/>
+            <a:off x="640080" y="2468880"/>
             <a:ext cx="10972800" cy="566928"/>
           </a:xfrm>
           <a:prstGeom prst="rect">
@@ -8029,13 +8068,13 @@
       </p:sp>
       <p:sp>
         <p:nvSpPr>
-          <p:cNvPr id="15" name="TextBox 14"/>
+          <p:cNvPr id="16" name="TextBox 15"/>
           <p:cNvSpPr txBox="1"/>
           <p:nvPr/>
         </p:nvSpPr>
         <p:spPr>
           <a:xfrm>
-            <a:off x="804672" y="2478024"/>
+            <a:off x="804672" y="2615184"/>
             <a:ext cx="2880360" cy="566928"/>
           </a:xfrm>
           <a:prstGeom prst="rect">
@@ -8068,13 +8107,13 @@
       </p:sp>
       <p:sp>
         <p:nvSpPr>
-          <p:cNvPr id="16" name="TextBox 15"/>
+          <p:cNvPr id="17" name="TextBox 16"/>
           <p:cNvSpPr txBox="1"/>
           <p:nvPr/>
         </p:nvSpPr>
         <p:spPr>
           <a:xfrm>
-            <a:off x="3913632" y="2478024"/>
+            <a:off x="3913632" y="2615184"/>
             <a:ext cx="1051559" cy="566928"/>
           </a:xfrm>
           <a:prstGeom prst="rect">
@@ -8107,13 +8146,13 @@
       </p:sp>
       <p:sp>
         <p:nvSpPr>
-          <p:cNvPr id="17" name="TextBox 16"/>
+          <p:cNvPr id="18" name="TextBox 17"/>
           <p:cNvSpPr txBox="1"/>
           <p:nvPr/>
         </p:nvSpPr>
         <p:spPr>
           <a:xfrm>
-            <a:off x="5193791" y="2478024"/>
+            <a:off x="5193791" y="2615184"/>
             <a:ext cx="1051559" cy="566928"/>
           </a:xfrm>
           <a:prstGeom prst="rect">
@@ -8146,13 +8185,13 @@
       </p:sp>
       <p:sp>
         <p:nvSpPr>
-          <p:cNvPr id="18" name="TextBox 17"/>
+          <p:cNvPr id="19" name="TextBox 18"/>
           <p:cNvSpPr txBox="1"/>
           <p:nvPr/>
         </p:nvSpPr>
         <p:spPr>
           <a:xfrm>
-            <a:off x="6473950" y="2478024"/>
+            <a:off x="6473950" y="2615184"/>
             <a:ext cx="1325880" cy="566928"/>
           </a:xfrm>
           <a:prstGeom prst="rect">
@@ -8185,13 +8224,13 @@
       </p:sp>
       <p:sp>
         <p:nvSpPr>
-          <p:cNvPr id="19" name="TextBox 18"/>
+          <p:cNvPr id="20" name="TextBox 19"/>
           <p:cNvSpPr txBox="1"/>
           <p:nvPr/>
         </p:nvSpPr>
         <p:spPr>
           <a:xfrm>
-            <a:off x="8028430" y="2478024"/>
+            <a:off x="8028430" y="2615184"/>
             <a:ext cx="1051559" cy="566928"/>
           </a:xfrm>
           <a:prstGeom prst="rect">
@@ -8224,13 +8263,13 @@
       </p:sp>
       <p:sp>
         <p:nvSpPr>
-          <p:cNvPr id="20" name="TextBox 19"/>
+          <p:cNvPr id="21" name="TextBox 20"/>
           <p:cNvSpPr txBox="1"/>
           <p:nvPr/>
         </p:nvSpPr>
         <p:spPr>
           <a:xfrm>
-            <a:off x="9308589" y="2478024"/>
+            <a:off x="9308589" y="2615184"/>
             <a:ext cx="2240280" cy="566928"/>
           </a:xfrm>
           <a:prstGeom prst="rect">
@@ -8263,13 +8302,13 @@
       </p:sp>
       <p:sp>
         <p:nvSpPr>
-          <p:cNvPr id="21" name="Rectangle 20"/>
+          <p:cNvPr id="22" name="Rectangle 21"/>
           <p:cNvSpPr/>
           <p:nvPr/>
         </p:nvSpPr>
         <p:spPr>
           <a:xfrm>
-            <a:off x="640080" y="2898648"/>
+            <a:off x="640080" y="3035808"/>
             <a:ext cx="10972800" cy="566928"/>
           </a:xfrm>
           <a:prstGeom prst="rect">
@@ -8309,13 +8348,13 @@
       </p:sp>
       <p:sp>
         <p:nvSpPr>
-          <p:cNvPr id="22" name="TextBox 21"/>
+          <p:cNvPr id="23" name="TextBox 22"/>
           <p:cNvSpPr txBox="1"/>
           <p:nvPr/>
         </p:nvSpPr>
         <p:spPr>
           <a:xfrm>
-            <a:off x="804672" y="3044952"/>
+            <a:off x="804672" y="3182112"/>
             <a:ext cx="2880360" cy="566928"/>
           </a:xfrm>
           <a:prstGeom prst="rect">
@@ -8348,13 +8387,13 @@
       </p:sp>
       <p:sp>
         <p:nvSpPr>
-          <p:cNvPr id="23" name="TextBox 22"/>
+          <p:cNvPr id="24" name="TextBox 23"/>
           <p:cNvSpPr txBox="1"/>
           <p:nvPr/>
         </p:nvSpPr>
         <p:spPr>
           <a:xfrm>
-            <a:off x="3913632" y="3044952"/>
+            <a:off x="3913632" y="3182112"/>
             <a:ext cx="1051559" cy="566928"/>
           </a:xfrm>
           <a:prstGeom prst="rect">
@@ -8387,13 +8426,13 @@
       </p:sp>
       <p:sp>
         <p:nvSpPr>
-          <p:cNvPr id="24" name="TextBox 23"/>
+          <p:cNvPr id="25" name="TextBox 24"/>
           <p:cNvSpPr txBox="1"/>
           <p:nvPr/>
         </p:nvSpPr>
         <p:spPr>
           <a:xfrm>
-            <a:off x="5193791" y="3044952"/>
+            <a:off x="5193791" y="3182112"/>
             <a:ext cx="1051559" cy="566928"/>
           </a:xfrm>
           <a:prstGeom prst="rect">
@@ -8426,13 +8465,13 @@
       </p:sp>
       <p:sp>
         <p:nvSpPr>
-          <p:cNvPr id="25" name="TextBox 24"/>
+          <p:cNvPr id="26" name="TextBox 25"/>
           <p:cNvSpPr txBox="1"/>
           <p:nvPr/>
         </p:nvSpPr>
         <p:spPr>
           <a:xfrm>
-            <a:off x="6473950" y="3044952"/>
+            <a:off x="6473950" y="3182112"/>
             <a:ext cx="1325880" cy="566928"/>
           </a:xfrm>
           <a:prstGeom prst="rect">
@@ -8465,13 +8504,13 @@
       </p:sp>
       <p:sp>
         <p:nvSpPr>
-          <p:cNvPr id="26" name="TextBox 25"/>
+          <p:cNvPr id="27" name="TextBox 26"/>
           <p:cNvSpPr txBox="1"/>
           <p:nvPr/>
         </p:nvSpPr>
         <p:spPr>
           <a:xfrm>
-            <a:off x="8028430" y="3044952"/>
+            <a:off x="8028430" y="3182112"/>
             <a:ext cx="1051559" cy="566928"/>
           </a:xfrm>
           <a:prstGeom prst="rect">
@@ -8504,13 +8543,13 @@
       </p:sp>
       <p:sp>
         <p:nvSpPr>
-          <p:cNvPr id="27" name="TextBox 26"/>
+          <p:cNvPr id="28" name="TextBox 27"/>
           <p:cNvSpPr txBox="1"/>
           <p:nvPr/>
         </p:nvSpPr>
         <p:spPr>
           <a:xfrm>
-            <a:off x="9308589" y="3044952"/>
+            <a:off x="9308589" y="3182112"/>
             <a:ext cx="2240280" cy="566928"/>
           </a:xfrm>
           <a:prstGeom prst="rect">
@@ -8543,13 +8582,13 @@
       </p:sp>
       <p:sp>
         <p:nvSpPr>
-          <p:cNvPr id="28" name="Rectangle 27"/>
+          <p:cNvPr id="29" name="Rectangle 28"/>
           <p:cNvSpPr/>
           <p:nvPr/>
         </p:nvSpPr>
         <p:spPr>
           <a:xfrm>
-            <a:off x="640080" y="3465576"/>
+            <a:off x="640080" y="3602736"/>
             <a:ext cx="10972800" cy="566928"/>
           </a:xfrm>
           <a:prstGeom prst="rect">
@@ -8589,13 +8628,13 @@
       </p:sp>
       <p:sp>
         <p:nvSpPr>
-          <p:cNvPr id="29" name="TextBox 28"/>
+          <p:cNvPr id="30" name="TextBox 29"/>
           <p:cNvSpPr txBox="1"/>
           <p:nvPr/>
         </p:nvSpPr>
         <p:spPr>
           <a:xfrm>
-            <a:off x="804672" y="3611880"/>
+            <a:off x="804672" y="3749040"/>
             <a:ext cx="2880360" cy="566928"/>
           </a:xfrm>
           <a:prstGeom prst="rect">
@@ -8628,13 +8667,13 @@
       </p:sp>
       <p:sp>
         <p:nvSpPr>
-          <p:cNvPr id="30" name="TextBox 29"/>
+          <p:cNvPr id="31" name="TextBox 30"/>
           <p:cNvSpPr txBox="1"/>
           <p:nvPr/>
         </p:nvSpPr>
         <p:spPr>
           <a:xfrm>
-            <a:off x="3913632" y="3611880"/>
+            <a:off x="3913632" y="3749040"/>
             <a:ext cx="1051559" cy="566928"/>
           </a:xfrm>
           <a:prstGeom prst="rect">
@@ -8667,13 +8706,13 @@
       </p:sp>
       <p:sp>
         <p:nvSpPr>
-          <p:cNvPr id="31" name="TextBox 30"/>
+          <p:cNvPr id="32" name="TextBox 31"/>
           <p:cNvSpPr txBox="1"/>
           <p:nvPr/>
         </p:nvSpPr>
         <p:spPr>
           <a:xfrm>
-            <a:off x="5193791" y="3611880"/>
+            <a:off x="5193791" y="3749040"/>
             <a:ext cx="1051559" cy="566928"/>
           </a:xfrm>
           <a:prstGeom prst="rect">
@@ -8706,13 +8745,13 @@
       </p:sp>
       <p:sp>
         <p:nvSpPr>
-          <p:cNvPr id="32" name="TextBox 31"/>
+          <p:cNvPr id="33" name="TextBox 32"/>
           <p:cNvSpPr txBox="1"/>
           <p:nvPr/>
         </p:nvSpPr>
         <p:spPr>
           <a:xfrm>
-            <a:off x="6473950" y="3611880"/>
+            <a:off x="6473950" y="3749040"/>
             <a:ext cx="1325880" cy="566928"/>
           </a:xfrm>
           <a:prstGeom prst="rect">
@@ -8745,13 +8784,13 @@
       </p:sp>
       <p:sp>
         <p:nvSpPr>
-          <p:cNvPr id="33" name="TextBox 32"/>
+          <p:cNvPr id="34" name="TextBox 33"/>
           <p:cNvSpPr txBox="1"/>
           <p:nvPr/>
         </p:nvSpPr>
         <p:spPr>
           <a:xfrm>
-            <a:off x="8028430" y="3611880"/>
+            <a:off x="8028430" y="3749040"/>
             <a:ext cx="1051559" cy="566928"/>
           </a:xfrm>
           <a:prstGeom prst="rect">
@@ -8784,13 +8823,13 @@
       </p:sp>
       <p:sp>
         <p:nvSpPr>
-          <p:cNvPr id="34" name="TextBox 33"/>
+          <p:cNvPr id="35" name="TextBox 34"/>
           <p:cNvSpPr txBox="1"/>
           <p:nvPr/>
         </p:nvSpPr>
         <p:spPr>
           <a:xfrm>
-            <a:off x="9308589" y="3611880"/>
+            <a:off x="9308589" y="3749040"/>
             <a:ext cx="2240280" cy="566928"/>
           </a:xfrm>
           <a:prstGeom prst="rect">
@@ -8823,13 +8862,13 @@
       </p:sp>
       <p:sp>
         <p:nvSpPr>
-          <p:cNvPr id="35" name="Rectangle 34"/>
+          <p:cNvPr id="36" name="Rectangle 35"/>
           <p:cNvSpPr/>
           <p:nvPr/>
         </p:nvSpPr>
         <p:spPr>
           <a:xfrm>
-            <a:off x="640080" y="4032504"/>
+            <a:off x="640080" y="4169664"/>
             <a:ext cx="10972800" cy="566928"/>
           </a:xfrm>
           <a:prstGeom prst="rect">
@@ -8869,13 +8908,13 @@
       </p:sp>
       <p:sp>
         <p:nvSpPr>
-          <p:cNvPr id="36" name="Rectangle 35"/>
+          <p:cNvPr id="37" name="Rectangle 36"/>
           <p:cNvSpPr/>
           <p:nvPr/>
         </p:nvSpPr>
         <p:spPr>
           <a:xfrm>
-            <a:off x="640080" y="4032504"/>
+            <a:off x="640080" y="4169664"/>
             <a:ext cx="109728" cy="566928"/>
           </a:xfrm>
           <a:prstGeom prst="rect">
@@ -8913,13 +8952,13 @@
       </p:sp>
       <p:sp>
         <p:nvSpPr>
-          <p:cNvPr id="37" name="TextBox 36"/>
+          <p:cNvPr id="38" name="TextBox 37"/>
           <p:cNvSpPr txBox="1"/>
           <p:nvPr/>
         </p:nvSpPr>
         <p:spPr>
           <a:xfrm>
-            <a:off x="804672" y="4178808"/>
+            <a:off x="804672" y="4315968"/>
             <a:ext cx="2880360" cy="566928"/>
           </a:xfrm>
           <a:prstGeom prst="rect">
@@ -8952,13 +8991,13 @@
       </p:sp>
       <p:sp>
         <p:nvSpPr>
-          <p:cNvPr id="38" name="TextBox 37"/>
+          <p:cNvPr id="39" name="TextBox 38"/>
           <p:cNvSpPr txBox="1"/>
           <p:nvPr/>
         </p:nvSpPr>
         <p:spPr>
           <a:xfrm>
-            <a:off x="3913632" y="4178808"/>
+            <a:off x="3913632" y="4315968"/>
             <a:ext cx="1051559" cy="566928"/>
           </a:xfrm>
           <a:prstGeom prst="rect">
@@ -8991,13 +9030,13 @@
       </p:sp>
       <p:sp>
         <p:nvSpPr>
-          <p:cNvPr id="39" name="TextBox 38"/>
+          <p:cNvPr id="40" name="TextBox 39"/>
           <p:cNvSpPr txBox="1"/>
           <p:nvPr/>
         </p:nvSpPr>
         <p:spPr>
           <a:xfrm>
-            <a:off x="5193791" y="4178808"/>
+            <a:off x="5193791" y="4315968"/>
             <a:ext cx="1051559" cy="566928"/>
           </a:xfrm>
           <a:prstGeom prst="rect">
@@ -9030,13 +9069,13 @@
       </p:sp>
       <p:sp>
         <p:nvSpPr>
-          <p:cNvPr id="40" name="TextBox 39"/>
+          <p:cNvPr id="41" name="TextBox 40"/>
           <p:cNvSpPr txBox="1"/>
           <p:nvPr/>
         </p:nvSpPr>
         <p:spPr>
           <a:xfrm>
-            <a:off x="6473950" y="4178808"/>
+            <a:off x="6473950" y="4315968"/>
             <a:ext cx="1325880" cy="566928"/>
           </a:xfrm>
           <a:prstGeom prst="rect">
@@ -9069,13 +9108,13 @@
       </p:sp>
       <p:sp>
         <p:nvSpPr>
-          <p:cNvPr id="41" name="TextBox 40"/>
+          <p:cNvPr id="42" name="TextBox 41"/>
           <p:cNvSpPr txBox="1"/>
           <p:nvPr/>
         </p:nvSpPr>
         <p:spPr>
           <a:xfrm>
-            <a:off x="8028430" y="4178808"/>
+            <a:off x="8028430" y="4315968"/>
             <a:ext cx="1051559" cy="566928"/>
           </a:xfrm>
           <a:prstGeom prst="rect">
@@ -9108,13 +9147,13 @@
       </p:sp>
       <p:sp>
         <p:nvSpPr>
-          <p:cNvPr id="42" name="TextBox 41"/>
+          <p:cNvPr id="43" name="TextBox 42"/>
           <p:cNvSpPr txBox="1"/>
           <p:nvPr/>
         </p:nvSpPr>
         <p:spPr>
           <a:xfrm>
-            <a:off x="9308589" y="4178808"/>
+            <a:off x="9308589" y="4315968"/>
             <a:ext cx="2240280" cy="566928"/>
           </a:xfrm>
           <a:prstGeom prst="rect">
@@ -9147,13 +9186,13 @@
       </p:sp>
       <p:sp>
         <p:nvSpPr>
-          <p:cNvPr id="43" name="Rectangle 42"/>
+          <p:cNvPr id="44" name="Rectangle 43"/>
           <p:cNvSpPr/>
           <p:nvPr/>
         </p:nvSpPr>
         <p:spPr>
           <a:xfrm>
-            <a:off x="640080" y="4873752"/>
+            <a:off x="640080" y="5010912"/>
             <a:ext cx="10972800" cy="777240"/>
           </a:xfrm>
           <a:prstGeom prst="rect">
@@ -9191,13 +9230,13 @@
       </p:sp>
       <p:sp>
         <p:nvSpPr>
-          <p:cNvPr id="44" name="TextBox 43"/>
+          <p:cNvPr id="45" name="TextBox 44"/>
           <p:cNvSpPr txBox="1"/>
           <p:nvPr/>
         </p:nvSpPr>
         <p:spPr>
           <a:xfrm>
-            <a:off x="868680" y="4983480"/>
+            <a:off x="868680" y="5120640"/>
             <a:ext cx="10515600" cy="320040"/>
           </a:xfrm>
           <a:prstGeom prst="rect">
@@ -9230,13 +9269,13 @@
       </p:sp>
       <p:sp>
         <p:nvSpPr>
-          <p:cNvPr id="45" name="TextBox 44"/>
+          <p:cNvPr id="46" name="TextBox 45"/>
           <p:cNvSpPr txBox="1"/>
           <p:nvPr/>
         </p:nvSpPr>
         <p:spPr>
           <a:xfrm>
-            <a:off x="868680" y="5239512"/>
+            <a:off x="868680" y="5376672"/>
             <a:ext cx="10515600" cy="457200"/>
           </a:xfrm>
           <a:prstGeom prst="rect">
@@ -9269,7 +9308,7 @@
       </p:sp>
       <p:sp>
         <p:nvSpPr>
-          <p:cNvPr id="46" name="Rectangle 45"/>
+          <p:cNvPr id="47" name="Rectangle 46"/>
           <p:cNvSpPr/>
           <p:nvPr/>
         </p:nvSpPr>
@@ -9313,7 +9352,7 @@
       </p:sp>
       <p:sp>
         <p:nvSpPr>
-          <p:cNvPr id="47" name="TextBox 46"/>
+          <p:cNvPr id="48" name="TextBox 47"/>
           <p:cNvSpPr txBox="1"/>
           <p:nvPr/>
         </p:nvSpPr>
@@ -9345,14 +9384,14 @@
                 </a:solidFill>
                 <a:latin typeface="Montserrat Ace"/>
               </a:rPr>
-              <a:t>VTV  ·  S5 MECE</a:t>
-            </a:r>
-          </a:p>
-        </p:txBody>
-      </p:sp>
-      <p:sp>
-        <p:nvSpPr>
-          <p:cNvPr id="48" name="TextBox 47"/>
+              <a:t>VTV  ·  S5 Decision</a:t>
+            </a:r>
+          </a:p>
+        </p:txBody>
+      </p:sp>
+      <p:sp>
+        <p:nvSpPr>
+          <p:cNvPr id="49" name="TextBox 48"/>
           <p:cNvSpPr txBox="1"/>
           <p:nvPr/>
         </p:nvSpPr>

</xml_diff>